<commit_message>
Corrige nomes das imagens (remove extensao duplicada .png.png)
- Renomeia screenshot_flashcards_game.png.png -> screenshot_flashcards_game.png
- Renomeia screenshot_paraphrase_text.png.png -> screenshot_paraphrase_text.png
- Renomeia screenshot_practice_conversation.png.png -> screenshot_practice_conversation.png
- Regenera apresentacao para incluir as figuras corretamente

https://claude.ai/code/session_01V8Sr7tzpSFf2ivEsTTkpRr
</commit_message>
<xml_diff>
--- a/CorrectMe_Apresentacao.pptx
+++ b/CorrectMe_Apresentacao.pptx
@@ -4425,89 +4425,33 @@
           </a:p>
         </p:txBody>
       </p:sp>
-      <p:sp>
-        <p:nvSpPr>
-          <p:cNvPr id="18" name="Rounded Rectangle 17"/>
-          <p:cNvSpPr/>
-          <p:nvPr/>
-        </p:nvSpPr>
+      <p:pic>
+        <p:nvPicPr>
+          <p:cNvPr id="18" name="Picture 17" descr="screenshot_paraphrase_text.png"/>
+          <p:cNvPicPr>
+            <a:picLocks noChangeAspect="1"/>
+          </p:cNvPicPr>
+          <p:nvPr/>
+        </p:nvPicPr>
+        <p:blipFill>
+          <a:blip r:embed="rId2"/>
+          <a:stretch>
+            <a:fillRect/>
+          </a:stretch>
+        </p:blipFill>
         <p:spPr>
           <a:xfrm>
             <a:off x="4572000" y="457200"/>
-            <a:ext cx="4297680" cy="3931920"/>
-          </a:xfrm>
-          <a:prstGeom prst="roundRect">
-            <a:avLst/>
-          </a:prstGeom>
-          <a:solidFill>
-            <a:srgbClr val="372A5C"/>
-          </a:solidFill>
-          <a:ln w="25400">
-            <a:solidFill>
-              <a:srgbClr val="F97316"/>
-            </a:solidFill>
-          </a:ln>
-        </p:spPr>
-        <p:style>
-          <a:lnRef idx="1">
-            <a:schemeClr val="accent1"/>
-          </a:lnRef>
-          <a:fillRef idx="3">
-            <a:schemeClr val="accent1"/>
-          </a:fillRef>
-          <a:effectRef idx="2">
-            <a:schemeClr val="accent1"/>
-          </a:effectRef>
-          <a:fontRef idx="minor">
-            <a:schemeClr val="lt1"/>
-          </a:fontRef>
-        </p:style>
-        <p:txBody>
-          <a:bodyPr rtlCol="0" anchor="ctr"/>
-          <a:lstStyle/>
-          <a:p>
-            <a:pPr algn="ctr"/>
-          </a:p>
-        </p:txBody>
-      </p:sp>
+            <a:ext cx="4297680" cy="4161159"/>
+          </a:xfrm>
+          <a:prstGeom prst="rect">
+            <a:avLst/>
+          </a:prstGeom>
+        </p:spPr>
+      </p:pic>
       <p:sp>
         <p:nvSpPr>
           <p:cNvPr id="19" name="TextBox 18"/>
-          <p:cNvSpPr txBox="1"/>
-          <p:nvPr/>
-        </p:nvSpPr>
-        <p:spPr>
-          <a:xfrm>
-            <a:off x="5029200" y="2103120"/>
-            <a:ext cx="3383280" cy="457200"/>
-          </a:xfrm>
-          <a:prstGeom prst="rect">
-            <a:avLst/>
-          </a:prstGeom>
-          <a:noFill/>
-        </p:spPr>
-        <p:txBody>
-          <a:bodyPr wrap="none">
-            <a:spAutoFit/>
-          </a:bodyPr>
-          <a:lstStyle/>
-          <a:p>
-            <a:pPr algn="ctr">
-              <a:defRPr sz="1400">
-                <a:solidFill>
-                  <a:srgbClr val="9CA3AF"/>
-                </a:solidFill>
-              </a:defRPr>
-            </a:pPr>
-            <a:r>
-              <a:t>[screenshot_paraphrase_text.png]</a:t>
-            </a:r>
-          </a:p>
-        </p:txBody>
-      </p:sp>
-      <p:sp>
-        <p:nvSpPr>
-          <p:cNvPr id="20" name="TextBox 19"/>
           <p:cNvSpPr txBox="1"/>
           <p:nvPr/>
         </p:nvSpPr>
@@ -14520,89 +14464,33 @@
           </a:p>
         </p:txBody>
       </p:sp>
-      <p:sp>
-        <p:nvSpPr>
-          <p:cNvPr id="18" name="Rounded Rectangle 17"/>
-          <p:cNvSpPr/>
-          <p:nvPr/>
-        </p:nvSpPr>
+      <p:pic>
+        <p:nvPicPr>
+          <p:cNvPr id="18" name="Picture 17" descr="screenshot_practice_conversation.png"/>
+          <p:cNvPicPr>
+            <a:picLocks noChangeAspect="1"/>
+          </p:cNvPicPr>
+          <p:nvPr/>
+        </p:nvPicPr>
+        <p:blipFill>
+          <a:blip r:embed="rId2"/>
+          <a:stretch>
+            <a:fillRect/>
+          </a:stretch>
+        </p:blipFill>
         <p:spPr>
           <a:xfrm>
             <a:off x="4572000" y="457200"/>
-            <a:ext cx="4297680" cy="3931920"/>
-          </a:xfrm>
-          <a:prstGeom prst="roundRect">
-            <a:avLst/>
-          </a:prstGeom>
-          <a:solidFill>
-            <a:srgbClr val="372A5C"/>
-          </a:solidFill>
-          <a:ln w="25400">
-            <a:solidFill>
-              <a:srgbClr val="22D3EE"/>
-            </a:solidFill>
-          </a:ln>
-        </p:spPr>
-        <p:style>
-          <a:lnRef idx="1">
-            <a:schemeClr val="accent1"/>
-          </a:lnRef>
-          <a:fillRef idx="3">
-            <a:schemeClr val="accent1"/>
-          </a:fillRef>
-          <a:effectRef idx="2">
-            <a:schemeClr val="accent1"/>
-          </a:effectRef>
-          <a:fontRef idx="minor">
-            <a:schemeClr val="lt1"/>
-          </a:fontRef>
-        </p:style>
-        <p:txBody>
-          <a:bodyPr rtlCol="0" anchor="ctr"/>
-          <a:lstStyle/>
-          <a:p>
-            <a:pPr algn="ctr"/>
-          </a:p>
-        </p:txBody>
-      </p:sp>
+            <a:ext cx="4297680" cy="1864435"/>
+          </a:xfrm>
+          <a:prstGeom prst="rect">
+            <a:avLst/>
+          </a:prstGeom>
+        </p:spPr>
+      </p:pic>
       <p:sp>
         <p:nvSpPr>
           <p:cNvPr id="19" name="TextBox 18"/>
-          <p:cNvSpPr txBox="1"/>
-          <p:nvPr/>
-        </p:nvSpPr>
-        <p:spPr>
-          <a:xfrm>
-            <a:off x="5029200" y="2103120"/>
-            <a:ext cx="3383280" cy="457200"/>
-          </a:xfrm>
-          <a:prstGeom prst="rect">
-            <a:avLst/>
-          </a:prstGeom>
-          <a:noFill/>
-        </p:spPr>
-        <p:txBody>
-          <a:bodyPr wrap="none">
-            <a:spAutoFit/>
-          </a:bodyPr>
-          <a:lstStyle/>
-          <a:p>
-            <a:pPr algn="ctr">
-              <a:defRPr sz="1400">
-                <a:solidFill>
-                  <a:srgbClr val="9CA3AF"/>
-                </a:solidFill>
-              </a:defRPr>
-            </a:pPr>
-            <a:r>
-              <a:t>[screenshot_practice_conversation.png]</a:t>
-            </a:r>
-          </a:p>
-        </p:txBody>
-      </p:sp>
-      <p:sp>
-        <p:nvSpPr>
-          <p:cNvPr id="20" name="TextBox 19"/>
           <p:cNvSpPr txBox="1"/>
           <p:nvPr/>
         </p:nvSpPr>
@@ -15994,89 +15882,33 @@
           </a:p>
         </p:txBody>
       </p:sp>
-      <p:sp>
-        <p:nvSpPr>
-          <p:cNvPr id="18" name="Rounded Rectangle 17"/>
-          <p:cNvSpPr/>
-          <p:nvPr/>
-        </p:nvSpPr>
+      <p:pic>
+        <p:nvPicPr>
+          <p:cNvPr id="18" name="Picture 17" descr="screenshot_flashcards_game.png"/>
+          <p:cNvPicPr>
+            <a:picLocks noChangeAspect="1"/>
+          </p:cNvPicPr>
+          <p:nvPr/>
+        </p:nvPicPr>
+        <p:blipFill>
+          <a:blip r:embed="rId2"/>
+          <a:stretch>
+            <a:fillRect/>
+          </a:stretch>
+        </p:blipFill>
         <p:spPr>
           <a:xfrm>
             <a:off x="4572000" y="457200"/>
-            <a:ext cx="4297680" cy="3931920"/>
-          </a:xfrm>
-          <a:prstGeom prst="roundRect">
-            <a:avLst/>
-          </a:prstGeom>
-          <a:solidFill>
-            <a:srgbClr val="372A5C"/>
-          </a:solidFill>
-          <a:ln w="25400">
-            <a:solidFill>
-              <a:srgbClr val="3B82F6"/>
-            </a:solidFill>
-          </a:ln>
-        </p:spPr>
-        <p:style>
-          <a:lnRef idx="1">
-            <a:schemeClr val="accent1"/>
-          </a:lnRef>
-          <a:fillRef idx="3">
-            <a:schemeClr val="accent1"/>
-          </a:fillRef>
-          <a:effectRef idx="2">
-            <a:schemeClr val="accent1"/>
-          </a:effectRef>
-          <a:fontRef idx="minor">
-            <a:schemeClr val="lt1"/>
-          </a:fontRef>
-        </p:style>
-        <p:txBody>
-          <a:bodyPr rtlCol="0" anchor="ctr"/>
-          <a:lstStyle/>
-          <a:p>
-            <a:pPr algn="ctr"/>
-          </a:p>
-        </p:txBody>
-      </p:sp>
+            <a:ext cx="4297680" cy="2852717"/>
+          </a:xfrm>
+          <a:prstGeom prst="rect">
+            <a:avLst/>
+          </a:prstGeom>
+        </p:spPr>
+      </p:pic>
       <p:sp>
         <p:nvSpPr>
           <p:cNvPr id="19" name="TextBox 18"/>
-          <p:cNvSpPr txBox="1"/>
-          <p:nvPr/>
-        </p:nvSpPr>
-        <p:spPr>
-          <a:xfrm>
-            <a:off x="5029200" y="2103120"/>
-            <a:ext cx="3383280" cy="457200"/>
-          </a:xfrm>
-          <a:prstGeom prst="rect">
-            <a:avLst/>
-          </a:prstGeom>
-          <a:noFill/>
-        </p:spPr>
-        <p:txBody>
-          <a:bodyPr wrap="none">
-            <a:spAutoFit/>
-          </a:bodyPr>
-          <a:lstStyle/>
-          <a:p>
-            <a:pPr algn="ctr">
-              <a:defRPr sz="1400">
-                <a:solidFill>
-                  <a:srgbClr val="9CA3AF"/>
-                </a:solidFill>
-              </a:defRPr>
-            </a:pPr>
-            <a:r>
-              <a:t>[screenshot_flashcards_game.png]</a:t>
-            </a:r>
-          </a:p>
-        </p:txBody>
-      </p:sp>
-      <p:sp>
-        <p:nvSpPr>
-          <p:cNvPr id="20" name="TextBox 19"/>
           <p:cNvSpPr txBox="1"/>
           <p:nvPr/>
         </p:nvSpPr>

</xml_diff>

<commit_message>
Corrige ortografia portuguesa - adiciona acentos em todo o texto
Correções incluem:
- Alemão, inteligência, correção, conversação, prática
- Índice, categorização, análise, público
- Tópicos, gramática, básico, avançado, classificação
- Você, declinação, conjugação, preposições, vocabulário
- Evolução, gráficos, estatísticas, distribuição, histórico
- Créditos, grátis, usuários, cartão, necessário
- Pedagógico, ortográfica, exportação, pronúncia
- Não, sinônimos, múltiplas, tradução, automática

https://claude.ai/code/session_01V8Sr7tzpSFf2ivEsTTkpRr
</commit_message>
<xml_diff>
--- a/CorrectMe_Apresentacao.pptx
+++ b/CorrectMe_Apresentacao.pptx
@@ -3320,7 +3320,7 @@
               </a:defRPr>
             </a:pPr>
             <a:r>
-              <a:t>Aprendizagem de Alemao com IA</a:t>
+              <a:t>Aprendizagem de Alemão com IA</a:t>
             </a:r>
           </a:p>
         </p:txBody>
@@ -3355,7 +3355,7 @@
               </a:defRPr>
             </a:pPr>
             <a:r>
-              <a:t>Plataforma completa de aprendizado de alemao com inteligencia artificial para brasileiros</a:t>
+              <a:t>Plataforma completa de aprendizado de alemão com inteligência artificial para brasileiros</a:t>
             </a:r>
           </a:p>
         </p:txBody>
@@ -3470,7 +3470,7 @@
               </a:defRPr>
             </a:pPr>
             <a:r>
-              <a:t>Correcao de Textos</a:t>
+              <a:t>Correção de Textos</a:t>
             </a:r>
           </a:p>
         </p:txBody>
@@ -3585,7 +3585,7 @@
               </a:defRPr>
             </a:pPr>
             <a:r>
-              <a:t>Pratica de Conversacao</a:t>
+              <a:t>Prática de Conversação</a:t>
             </a:r>
           </a:p>
         </p:txBody>
@@ -3936,7 +3936,7 @@
               </a:defRPr>
             </a:pPr>
             <a:r>
-              <a:t>Transforme seu texto alemao em diferentes estilos: formal, casual, com emojis, simplificado e mais.</a:t>
+              <a:t>Transforme seu texto alemão em diferentes estilos: formal, casual, com emojis, simplificado e mais.</a:t>
             </a:r>
           </a:p>
         </p:txBody>
@@ -4178,7 +4178,7 @@
               </a:defRPr>
             </a:pPr>
             <a:r>
-              <a:t>Mantem o significado original</a:t>
+              <a:t>Mantém o significado original</a:t>
             </a:r>
           </a:p>
         </p:txBody>
@@ -4299,7 +4299,7 @@
               </a:defRPr>
             </a:pPr>
             <a:r>
-              <a:t>Ideal para aprender sinonimos</a:t>
+              <a:t>Ideal para aprender sinônimos</a:t>
             </a:r>
           </a:p>
         </p:txBody>
@@ -4420,7 +4420,7 @@
               </a:defRPr>
             </a:pPr>
             <a:r>
-              <a:t>Melhore seu vocabulario ativo</a:t>
+              <a:t>Melhore seu vocabulário ativo</a:t>
             </a:r>
           </a:p>
         </p:txBody>
@@ -4803,7 +4803,7 @@
               </a:defRPr>
             </a:pPr>
             <a:r>
-              <a:t>Cole ou digite sua redacao em alemao. Nosso editor inteligente aceita qualquer texto.</a:t>
+              <a:t>Cole ou digite sua redação em alemão. Nosso editor inteligente aceita qualquer texto.</a:t>
             </a:r>
           </a:p>
         </p:txBody>
@@ -4961,7 +4961,7 @@
               </a:defRPr>
             </a:pPr>
             <a:r>
-              <a:t>Receba a analise</a:t>
+              <a:t>Receba a análise</a:t>
             </a:r>
           </a:p>
         </p:txBody>
@@ -4996,7 +4996,7 @@
               </a:defRPr>
             </a:pPr>
             <a:r>
-              <a:t>Nossa IA identifica erros, categoriza por tipo e explica cada correcao em portugues.</a:t>
+              <a:t>Nossa IA identifica erros, categoriza por tipo e explica cada correção em português.</a:t>
             </a:r>
           </a:p>
         </p:txBody>
@@ -5154,7 +5154,7 @@
               </a:defRPr>
             </a:pPr>
             <a:r>
-              <a:t>Acompanhe sua evolucao</a:t>
+              <a:t>Acompanhe sua evolução</a:t>
             </a:r>
           </a:p>
         </p:txBody>
@@ -5390,7 +5390,7 @@
               </a:defRPr>
             </a:pPr>
             <a:r>
-              <a:t>Analise de Custo</a:t>
+              <a:t>Análise de Custo</a:t>
             </a:r>
           </a:p>
         </p:txBody>
@@ -5425,7 +5425,7 @@
               </a:defRPr>
             </a:pPr>
             <a:r>
-              <a:t>Investimento acessivel para um aprendizado de qualidade</a:t>
+              <a:t>Investimento acessível para um aprendizado de qualidade</a:t>
             </a:r>
           </a:p>
         </p:txBody>
@@ -5460,7 +5460,7 @@
               </a:defRPr>
             </a:pPr>
             <a:r>
-              <a:t>Sistema de Creditos</a:t>
+              <a:t>Sistema de Créditos</a:t>
             </a:r>
           </a:p>
         </p:txBody>
@@ -5538,7 +5538,7 @@
               </a:defRPr>
             </a:pPr>
             <a:r>
-              <a:t>100 creditos</a:t>
+              <a:t>100 créditos</a:t>
             </a:r>
           </a:p>
         </p:txBody>
@@ -5573,7 +5573,7 @@
               </a:defRPr>
             </a:pPr>
             <a:r>
-              <a:t>Gratis para novos usuarios</a:t>
+              <a:t>Grátis para novos usuários</a:t>
             </a:r>
           </a:p>
         </p:txBody>
@@ -5651,7 +5651,7 @@
               </a:defRPr>
             </a:pPr>
             <a:r>
-              <a:t>Correcao de texto</a:t>
+              <a:t>Correção de texto</a:t>
             </a:r>
           </a:p>
         </p:txBody>
@@ -5686,7 +5686,7 @@
               </a:defRPr>
             </a:pPr>
             <a:r>
-              <a:t>~1 credito por correcao</a:t>
+              <a:t>~1 crédito por correção</a:t>
             </a:r>
           </a:p>
         </p:txBody>
@@ -5764,7 +5764,7 @@
               </a:defRPr>
             </a:pPr>
             <a:r>
-              <a:t>Pratica de conversacao</a:t>
+              <a:t>Prática de conversação</a:t>
             </a:r>
           </a:p>
         </p:txBody>
@@ -5799,7 +5799,7 @@
               </a:defRPr>
             </a:pPr>
             <a:r>
-              <a:t>10 creditos/minuto</a:t>
+              <a:t>10 créditos/minuto</a:t>
             </a:r>
           </a:p>
         </p:txBody>
@@ -5877,7 +5877,7 @@
               </a:defRPr>
             </a:pPr>
             <a:r>
-              <a:t>Parafrase de texto</a:t>
+              <a:t>Paráfrase de texto</a:t>
             </a:r>
           </a:p>
         </p:txBody>
@@ -5912,7 +5912,7 @@
               </a:defRPr>
             </a:pPr>
             <a:r>
-              <a:t>~1 credito por uso</a:t>
+              <a:t>~1 crédito por uso</a:t>
             </a:r>
           </a:p>
         </p:txBody>
@@ -6286,7 +6286,7 @@
               </a:defRPr>
             </a:pPr>
             <a:r>
-              <a:t>R$ 300-800/mes</a:t>
+              <a:t>R$ 300-800/mês</a:t>
             </a:r>
           </a:p>
         </p:txBody>
@@ -6399,7 +6399,7 @@
               </a:defRPr>
             </a:pPr>
             <a:r>
-              <a:t>R$ 50-100/mes</a:t>
+              <a:t>R$ 50-100/mês</a:t>
             </a:r>
           </a:p>
         </p:txBody>
@@ -6592,7 +6592,7 @@
               </a:defRPr>
             </a:pPr>
             <a:r>
-              <a:t>Comece gratis com 100 creditos - Sem cartao de credito necessario!</a:t>
+              <a:t>Comece grátis com 100 créditos - Sem cartão de crédito necessário!</a:t>
             </a:r>
           </a:p>
         </p:txBody>
@@ -6984,7 +6984,7 @@
               </a:defRPr>
             </a:pPr>
             <a:r>
-              <a:t>Especializado em alemao</a:t>
+              <a:t>Especializado em alemão</a:t>
             </a:r>
           </a:p>
         </p:txBody>
@@ -7124,7 +7124,7 @@
               </a:defRPr>
             </a:pPr>
             <a:r>
-              <a:t>Feedback pedagogico</a:t>
+              <a:t>Feedback pedagógico</a:t>
             </a:r>
           </a:p>
         </p:txBody>
@@ -7194,7 +7194,7 @@
               </a:defRPr>
             </a:pPr>
             <a:r>
-              <a:t>Nao</a:t>
+              <a:t>Não</a:t>
             </a:r>
           </a:p>
         </p:txBody>
@@ -7307,7 +7307,7 @@
               </a:defRPr>
             </a:pPr>
             <a:r>
-              <a:t>Categorizacao de erros</a:t>
+              <a:t>Categorização de erros</a:t>
             </a:r>
           </a:p>
         </p:txBody>
@@ -7377,7 +7377,7 @@
               </a:defRPr>
             </a:pPr>
             <a:r>
-              <a:t>Nao</a:t>
+              <a:t>Não</a:t>
             </a:r>
           </a:p>
         </p:txBody>
@@ -7412,7 +7412,7 @@
               </a:defRPr>
             </a:pPr>
             <a:r>
-              <a:t>Nao</a:t>
+              <a:t>Não</a:t>
             </a:r>
           </a:p>
         </p:txBody>
@@ -7517,7 +7517,7 @@
               </a:defRPr>
             </a:pPr>
             <a:r>
-              <a:t>Nao</a:t>
+              <a:t>Não</a:t>
             </a:r>
           </a:p>
         </p:txBody>
@@ -7552,7 +7552,7 @@
               </a:defRPr>
             </a:pPr>
             <a:r>
-              <a:t>Nao</a:t>
+              <a:t>Não</a:t>
             </a:r>
           </a:p>
         </p:txBody>
@@ -7630,7 +7630,7 @@
               </a:defRPr>
             </a:pPr>
             <a:r>
-              <a:t>Listas de vocabulario</a:t>
+              <a:t>Listas de vocabulário</a:t>
             </a:r>
           </a:p>
         </p:txBody>
@@ -7700,7 +7700,7 @@
               </a:defRPr>
             </a:pPr>
             <a:r>
-              <a:t>Nao</a:t>
+              <a:t>Não</a:t>
             </a:r>
           </a:p>
         </p:txBody>
@@ -7735,7 +7735,7 @@
               </a:defRPr>
             </a:pPr>
             <a:r>
-              <a:t>Nao</a:t>
+              <a:t>Não</a:t>
             </a:r>
           </a:p>
         </p:txBody>
@@ -7770,7 +7770,7 @@
               </a:defRPr>
             </a:pPr>
             <a:r>
-              <a:t>Chatbot para pratica</a:t>
+              <a:t>Chatbot para prática</a:t>
             </a:r>
           </a:p>
         </p:txBody>
@@ -7840,7 +7840,7 @@
               </a:defRPr>
             </a:pPr>
             <a:r>
-              <a:t>Nao</a:t>
+              <a:t>Não</a:t>
             </a:r>
           </a:p>
         </p:txBody>
@@ -7875,7 +7875,7 @@
               </a:defRPr>
             </a:pPr>
             <a:r>
-              <a:t>Nao</a:t>
+              <a:t>Não</a:t>
             </a:r>
           </a:p>
         </p:txBody>
@@ -7953,7 +7953,7 @@
               </a:defRPr>
             </a:pPr>
             <a:r>
-              <a:t>Pratica de conversacao</a:t>
+              <a:t>Prática de conversação</a:t>
             </a:r>
           </a:p>
         </p:txBody>
@@ -8023,7 +8023,7 @@
               </a:defRPr>
             </a:pPr>
             <a:r>
-              <a:t>Nao</a:t>
+              <a:t>Não</a:t>
             </a:r>
           </a:p>
         </p:txBody>
@@ -8058,7 +8058,7 @@
               </a:defRPr>
             </a:pPr>
             <a:r>
-              <a:t>Nao</a:t>
+              <a:t>Não</a:t>
             </a:r>
           </a:p>
         </p:txBody>
@@ -8505,7 +8505,7 @@
               </a:defRPr>
             </a:pPr>
             <a:r>
-              <a:t>Que precisam escrever em alemao no trabalho</a:t>
+              <a:t>Que precisam escrever em alemão no trabalho</a:t>
             </a:r>
           </a:p>
         </p:txBody>
@@ -8663,7 +8663,7 @@
               </a:defRPr>
             </a:pPr>
             <a:r>
-              <a:t>Que querem otimizar correcoes de alunos</a:t>
+              <a:t>Que querem otimizar correções de alunos</a:t>
             </a:r>
           </a:p>
         </p:txBody>
@@ -8821,7 +8821,7 @@
               </a:defRPr>
             </a:pPr>
             <a:r>
-              <a:t>De qualquer nivel, do iniciante ao avancado</a:t>
+              <a:t>De qualquer nível, do iniciante ao avançado</a:t>
             </a:r>
           </a:p>
         </p:txBody>
@@ -9019,7 +9019,7 @@
               </a:defRPr>
             </a:pPr>
             <a:r>
-              <a:t>Comece a dominar o alemao hoje!</a:t>
+              <a:t>Comece a dominar o alemão hoje!</a:t>
             </a:r>
           </a:p>
         </p:txBody>
@@ -9054,7 +9054,7 @@
               </a:defRPr>
             </a:pPr>
             <a:r>
-              <a:t>Experimente gratis - 100 creditos para novos usuarios</a:t>
+              <a:t>Experimente grátis - 100 créditos para novos usuários</a:t>
             </a:r>
           </a:p>
         </p:txBody>
@@ -9300,7 +9300,7 @@
               </a:defRPr>
             </a:pPr>
             <a:r>
-              <a:t>Indice</a:t>
+              <a:t>Índice</a:t>
             </a:r>
           </a:p>
         </p:txBody>
@@ -9553,7 +9553,7 @@
               </a:defRPr>
             </a:pPr>
             <a:r>
-              <a:t>Sistema de Categorizacao de Erros</a:t>
+              <a:t>Sistema de Categorização de Erros</a:t>
             </a:r>
           </a:p>
         </p:txBody>
@@ -9868,7 +9868,7 @@
               </a:defRPr>
             </a:pPr>
             <a:r>
-              <a:t>Analise de Custo</a:t>
+              <a:t>Análise de Custo</a:t>
             </a:r>
           </a:p>
         </p:txBody>
@@ -10078,7 +10078,7 @@
               </a:defRPr>
             </a:pPr>
             <a:r>
-              <a:t>Publico Alvo</a:t>
+              <a:t>Público Alvo</a:t>
             </a:r>
           </a:p>
         </p:txBody>
@@ -10244,7 +10244,7 @@
               </a:defRPr>
             </a:pPr>
             <a:r>
-              <a:t>Por que o CorrectMe e a melhor escolha para aprender alemao</a:t>
+              <a:t>Por que o CorrectMe é a melhor escolha para aprender alemão</a:t>
             </a:r>
           </a:p>
         </p:txBody>
@@ -10402,7 +10402,7 @@
               </a:defRPr>
             </a:pPr>
             <a:r>
-              <a:t>Topicos de Gramatica</a:t>
+              <a:t>Tópicos de Gramática</a:t>
             </a:r>
           </a:p>
         </p:txBody>
@@ -10437,7 +10437,7 @@
               </a:defRPr>
             </a:pPr>
             <a:r>
-              <a:t>Cobertura completa de todos os topicos gramaticais do alemao, do basico ao avancado</a:t>
+              <a:t>Cobertura completa de todos os tópicos gramaticais do alemão, do básico ao avançado</a:t>
             </a:r>
           </a:p>
         </p:txBody>
@@ -10630,7 +10630,7 @@
               </a:defRPr>
             </a:pPr>
             <a:r>
-              <a:t>Pratica com diferentes personagens e contextos do cotidiano alemao</a:t>
+              <a:t>Prática com diferentes personagens e contextos do cotidiano alemão</a:t>
             </a:r>
           </a:p>
         </p:txBody>
@@ -10823,7 +10823,7 @@
               </a:defRPr>
             </a:pPr>
             <a:r>
-              <a:t>Classificacao inteligente que ajuda a focar nos seus pontos fracos</a:t>
+              <a:t>Classificação inteligente que ajuda a focar nos seus pontos fracos</a:t>
             </a:r>
           </a:p>
         </p:txBody>
@@ -10981,7 +10981,7 @@
               </a:defRPr>
             </a:pPr>
             <a:r>
-              <a:t>Disponivel Sempre</a:t>
+              <a:t>Disponível Sempre</a:t>
             </a:r>
           </a:p>
         </p:txBody>
@@ -11016,7 +11016,7 @@
               </a:defRPr>
             </a:pPr>
             <a:r>
-              <a:t>Acesso ilimitado a plataforma, estude quando e onde quiser</a:t>
+              <a:t>Acesso ilimitado à plataforma, estude quando e onde quiser</a:t>
             </a:r>
           </a:p>
         </p:txBody>
@@ -11147,7 +11147,7 @@
               </a:defRPr>
             </a:pPr>
             <a:r>
-              <a:t>Entenda Exatamente Onde Voce Erra</a:t>
+              <a:t>Entenda Exatamente Onde Você Erra</a:t>
             </a:r>
           </a:p>
         </p:txBody>
@@ -11182,11 +11182,11 @@
               </a:defRPr>
             </a:pPr>
             <a:r>
-              <a:t>Nosso sistema exclusivo de categorizacao identifica e classifica cada erro por cor, </a:t>
+              <a:t>Nosso sistema exclusivo de categorização identifica e classifica cada erro por cor, </a:t>
             </a:r>
             <a:br/>
             <a:r>
-              <a:t>permitindo que voce foque exatamente nos pontos que precisa melhorar</a:t>
+              <a:t>permitindo que você foque exatamente nos pontos que precisa melhorar</a:t>
             </a:r>
           </a:p>
         </p:txBody>
@@ -11350,7 +11350,7 @@
               </a:defRPr>
             </a:pPr>
             <a:r>
-              <a:t>Declinacao</a:t>
+              <a:t>Declinação</a:t>
             </a:r>
           </a:p>
         </p:txBody>
@@ -11385,7 +11385,7 @@
               </a:defRPr>
             </a:pPr>
             <a:r>
-              <a:t>Genus, Numerus, Kasus - Os 3 pilares da gramatica alema</a:t>
+              <a:t>Genus, Numerus, Kasus - Os 3 pilares da gramática alemã</a:t>
             </a:r>
           </a:p>
         </p:txBody>
@@ -11584,7 +11584,7 @@
               </a:defRPr>
             </a:pPr>
             <a:r>
-              <a:t>Conjugacao</a:t>
+              <a:t>Conjugação</a:t>
             </a:r>
           </a:p>
         </p:txBody>
@@ -11818,7 +11818,7 @@
               </a:defRPr>
             </a:pPr>
             <a:r>
-              <a:t>Preposicoes</a:t>
+              <a:t>Preposições</a:t>
             </a:r>
           </a:p>
         </p:txBody>
@@ -11888,7 +11888,7 @@
               </a:defRPr>
             </a:pPr>
             <a:r>
-              <a:t>Saiba qual preposicao usar e com qual caso</a:t>
+              <a:t>Saiba qual preposição usar e com qual caso</a:t>
             </a:r>
           </a:p>
         </p:txBody>
@@ -12122,7 +12122,7 @@
               </a:defRPr>
             </a:pPr>
             <a:r>
-              <a:t>Construa frases com a ordem correta alemao</a:t>
+              <a:t>Construa frases com a ordem correta do alemão</a:t>
             </a:r>
           </a:p>
         </p:txBody>
@@ -12286,7 +12286,7 @@
               </a:defRPr>
             </a:pPr>
             <a:r>
-              <a:t>Vocabulario</a:t>
+              <a:t>Vocabulário</a:t>
             </a:r>
           </a:p>
         </p:txBody>
@@ -12321,7 +12321,7 @@
               </a:defRPr>
             </a:pPr>
             <a:r>
-              <a:t>Escolha de palavras e expressoes</a:t>
+              <a:t>Escolha de palavras e expressões</a:t>
             </a:r>
           </a:p>
         </p:txBody>
@@ -12487,7 +12487,7 @@
               </a:defRPr>
             </a:pPr>
             <a:r>
-              <a:t>CORRECAO INTELIGENTE</a:t>
+              <a:t>CORREÇÃO INTELIGENTE</a:t>
             </a:r>
           </a:p>
         </p:txBody>
@@ -12557,7 +12557,7 @@
               </a:defRPr>
             </a:pPr>
             <a:r>
-              <a:t>Nossa IA identifica erros de declinacao, conjugacao, sintaxe, preposicoes e vocabulario, destacando cada um com cores diferentes para facilitar o aprendizado.</a:t>
+              <a:t>Nossa IA identifica erros de declinação, conjugação, sintaxe, preposições e vocabulário, destacando cada um com cores diferentes para facilitar o aprendizado.</a:t>
             </a:r>
           </a:p>
         </p:txBody>
@@ -12678,7 +12678,7 @@
               </a:defRPr>
             </a:pPr>
             <a:r>
-              <a:t>Correcao gramatical e ortografica em tempo real</a:t>
+              <a:t>Correção gramatical e ortográfica em tempo real</a:t>
             </a:r>
           </a:p>
         </p:txBody>
@@ -12799,7 +12799,7 @@
               </a:defRPr>
             </a:pPr>
             <a:r>
-              <a:t>Feedback pedagogico que explica o 'porque' de cada erro</a:t>
+              <a:t>Feedback pedagógico que explica o 'porquê' de cada erro</a:t>
             </a:r>
           </a:p>
         </p:txBody>
@@ -13041,7 +13041,7 @@
               </a:defRPr>
             </a:pPr>
             <a:r>
-              <a:t>Exportacao do texto corrigido</a:t>
+              <a:t>Exportação do texto corrigido</a:t>
             </a:r>
           </a:p>
         </p:txBody>
@@ -13231,7 +13231,7 @@
               </a:defRPr>
             </a:pPr>
             <a:r>
-              <a:t>Visualize sua evolucao em tempo real</a:t>
+              <a:t>Visualize sua evolução em tempo real</a:t>
             </a:r>
           </a:p>
         </p:txBody>
@@ -13266,7 +13266,7 @@
               </a:defRPr>
             </a:pPr>
             <a:r>
-              <a:t>Dashboard completo com graficos e estatisticas detalhadas para acompanhar seu desenvolvimento no alemao.</a:t>
+              <a:t>Dashboard completo com gráficos e estatísticas detalhadas para acompanhar seu desenvolvimento no alemão.</a:t>
             </a:r>
           </a:p>
         </p:txBody>
@@ -13387,7 +13387,7 @@
               </a:defRPr>
             </a:pPr>
             <a:r>
-              <a:t>Grafico de distribuicao de erros por categoria</a:t>
+              <a:t>Gráfico de distribuição de erros por categoria</a:t>
             </a:r>
           </a:p>
         </p:txBody>
@@ -13508,7 +13508,7 @@
               </a:defRPr>
             </a:pPr>
             <a:r>
-              <a:t>Historico de erros por redacao</a:t>
+              <a:t>Histórico de erros por redação</a:t>
             </a:r>
           </a:p>
         </p:txBody>
@@ -13629,7 +13629,7 @@
               </a:defRPr>
             </a:pPr>
             <a:r>
-              <a:t>Estatisticas gerais de performance</a:t>
+              <a:t>Estatísticas gerais de performance</a:t>
             </a:r>
           </a:p>
         </p:txBody>
@@ -13750,7 +13750,7 @@
               </a:defRPr>
             </a:pPr>
             <a:r>
-              <a:t>Tracking de evolucao ao longo do tempo</a:t>
+              <a:t>Tracking de evolução ao longo do tempo</a:t>
             </a:r>
           </a:p>
         </p:txBody>
@@ -13905,7 +13905,7 @@
               </a:defRPr>
             </a:pPr>
             <a:r>
-              <a:t>PRATICA DE CONVERSACAO</a:t>
+              <a:t>PRÁTICA DE CONVERSAÇÃO</a:t>
             </a:r>
           </a:p>
         </p:txBody>
@@ -13940,7 +13940,7 @@
               </a:defRPr>
             </a:pPr>
             <a:r>
-              <a:t>Pratique alemao falado com IA</a:t>
+              <a:t>Pratique alemão falado com IA</a:t>
             </a:r>
           </a:p>
         </p:txBody>
@@ -14096,7 +14096,7 @@
               </a:defRPr>
             </a:pPr>
             <a:r>
-              <a:t>10 personagens com diferentes profissoes</a:t>
+              <a:t>10 personagens com diferentes profissões</a:t>
             </a:r>
           </a:p>
         </p:txBody>
@@ -14217,7 +14217,7 @@
               </a:defRPr>
             </a:pPr>
             <a:r>
-              <a:t>Reconhecimento de voz em alemao</a:t>
+              <a:t>Reconhecimento de voz em alemão</a:t>
             </a:r>
           </a:p>
         </p:txBody>
@@ -14338,7 +14338,7 @@
               </a:defRPr>
             </a:pPr>
             <a:r>
-              <a:t>Analise de erros apos a conversa</a:t>
+              <a:t>Análise de erros após a conversa</a:t>
             </a:r>
           </a:p>
         </p:txBody>
@@ -14459,7 +14459,7 @@
               </a:defRPr>
             </a:pPr>
             <a:r>
-              <a:t>Pratica de escuta e pronuncia</a:t>
+              <a:t>Prática de escuta e pronúncia</a:t>
             </a:r>
           </a:p>
         </p:txBody>
@@ -14614,7 +14614,7 @@
               </a:defRPr>
             </a:pPr>
             <a:r>
-              <a:t>LISTAS DE VOCABULARIO</a:t>
+              <a:t>LISTAS DE VOCABULÁRIO</a:t>
             </a:r>
           </a:p>
         </p:txBody>
@@ -14649,7 +14649,7 @@
               </a:defRPr>
             </a:pPr>
             <a:r>
-              <a:t>Organize e pratique seu vocabulario</a:t>
+              <a:t>Organize e pratique seu vocabulário</a:t>
             </a:r>
           </a:p>
         </p:txBody>
@@ -14684,7 +14684,7 @@
               </a:defRPr>
             </a:pPr>
             <a:r>
-              <a:t>Crie listas personalizadas, importe palavras via CSV e classifique por nivel de dificuldade.</a:t>
+              <a:t>Crie listas personalizadas, importe palavras via CSV e classifique por nível de dificuldade.</a:t>
             </a:r>
           </a:p>
         </p:txBody>
@@ -14805,7 +14805,7 @@
               </a:defRPr>
             </a:pPr>
             <a:r>
-              <a:t>Multiplas listas organizadas por tema</a:t>
+              <a:t>Múltiplas listas organizadas por tema</a:t>
             </a:r>
           </a:p>
         </p:txBody>
@@ -14926,7 +14926,7 @@
               </a:defRPr>
             </a:pPr>
             <a:r>
-              <a:t>Importacao de CSV</a:t>
+              <a:t>Importação de CSV</a:t>
             </a:r>
           </a:p>
         </p:txBody>
@@ -15047,7 +15047,7 @@
               </a:defRPr>
             </a:pPr>
             <a:r>
-              <a:t>Classificacao por dificuldade (vermelho/amarelo/verde)</a:t>
+              <a:t>Classificação por dificuldade (vermelho/amarelo/verde)</a:t>
             </a:r>
           </a:p>
         </p:txBody>
@@ -15168,7 +15168,7 @@
               </a:defRPr>
             </a:pPr>
             <a:r>
-              <a:t>Traducao automatica para portugues</a:t>
+              <a:t>Tradução automática para português</a:t>
             </a:r>
           </a:p>
         </p:txBody>
@@ -15393,7 +15393,7 @@
               </a:defRPr>
             </a:pPr>
             <a:r>
-              <a:t>Teste seu conhecimento com flashcards interativos e jogos como o jogo da forca alemao.</a:t>
+              <a:t>Teste seu conhecimento com flashcards interativos e jogos como o jogo da forca alemão.</a:t>
             </a:r>
           </a:p>
         </p:txBody>
@@ -15514,7 +15514,7 @@
               </a:defRPr>
             </a:pPr>
             <a:r>
-              <a:t>Flashcards automaticos a partir das redacoes</a:t>
+              <a:t>Flashcards automáticos a partir das redações</a:t>
             </a:r>
           </a:p>
         </p:txBody>
@@ -15756,7 +15756,7 @@
               </a:defRPr>
             </a:pPr>
             <a:r>
-              <a:t>Filtro por nivel de dificuldade</a:t>
+              <a:t>Filtro por nível de dificuldade</a:t>
             </a:r>
           </a:p>
         </p:txBody>
@@ -15877,7 +15877,7 @@
               </a:defRPr>
             </a:pPr>
             <a:r>
-              <a:t>Pratica de artigos (der/die/das)</a:t>
+              <a:t>Prática de artigos (der/die/das)</a:t>
             </a:r>
           </a:p>
         </p:txBody>

</xml_diff>

<commit_message>
Corrige nome do arquivo Parafrasear.png e regenera apresentação
- Corrige referência parafrasear.png -> Parafrasear.png (case-sensitive)
- Regenera apresentação com todas as imagens do chatbot

https://claude.ai/code/session_01V8Sr7tzpSFf2ivEsTTkpRr
</commit_message>
<xml_diff>
--- a/CorrectMe_Apresentacao.pptx
+++ b/CorrectMe_Apresentacao.pptx
@@ -4427,89 +4427,33 @@
           </a:p>
         </p:txBody>
       </p:sp>
-      <p:sp>
-        <p:nvSpPr>
-          <p:cNvPr id="18" name="Rounded Rectangle 17"/>
-          <p:cNvSpPr/>
-          <p:nvPr/>
-        </p:nvSpPr>
+      <p:pic>
+        <p:nvPicPr>
+          <p:cNvPr id="18" name="Picture 17" descr="Parafrasear.png"/>
+          <p:cNvPicPr>
+            <a:picLocks noChangeAspect="1"/>
+          </p:cNvPicPr>
+          <p:nvPr/>
+        </p:nvPicPr>
+        <p:blipFill>
+          <a:blip r:embed="rId2"/>
+          <a:stretch>
+            <a:fillRect/>
+          </a:stretch>
+        </p:blipFill>
         <p:spPr>
           <a:xfrm>
             <a:off x="4572000" y="457200"/>
-            <a:ext cx="4297680" cy="3931920"/>
-          </a:xfrm>
-          <a:prstGeom prst="roundRect">
-            <a:avLst/>
-          </a:prstGeom>
-          <a:solidFill>
-            <a:srgbClr val="372A5C"/>
-          </a:solidFill>
-          <a:ln w="25400">
-            <a:solidFill>
-              <a:srgbClr val="F97316"/>
-            </a:solidFill>
-          </a:ln>
-        </p:spPr>
-        <p:style>
-          <a:lnRef idx="1">
-            <a:schemeClr val="accent1"/>
-          </a:lnRef>
-          <a:fillRef idx="3">
-            <a:schemeClr val="accent1"/>
-          </a:fillRef>
-          <a:effectRef idx="2">
-            <a:schemeClr val="accent1"/>
-          </a:effectRef>
-          <a:fontRef idx="minor">
-            <a:schemeClr val="lt1"/>
-          </a:fontRef>
-        </p:style>
-        <p:txBody>
-          <a:bodyPr rtlCol="0" anchor="ctr"/>
-          <a:lstStyle/>
-          <a:p>
-            <a:pPr algn="ctr"/>
-          </a:p>
-        </p:txBody>
-      </p:sp>
+            <a:ext cx="4297680" cy="2111420"/>
+          </a:xfrm>
+          <a:prstGeom prst="rect">
+            <a:avLst/>
+          </a:prstGeom>
+        </p:spPr>
+      </p:pic>
       <p:sp>
         <p:nvSpPr>
           <p:cNvPr id="19" name="TextBox 18"/>
-          <p:cNvSpPr txBox="1"/>
-          <p:nvPr/>
-        </p:nvSpPr>
-        <p:spPr>
-          <a:xfrm>
-            <a:off x="5029200" y="2103120"/>
-            <a:ext cx="3383280" cy="457200"/>
-          </a:xfrm>
-          <a:prstGeom prst="rect">
-            <a:avLst/>
-          </a:prstGeom>
-          <a:noFill/>
-        </p:spPr>
-        <p:txBody>
-          <a:bodyPr wrap="none">
-            <a:spAutoFit/>
-          </a:bodyPr>
-          <a:lstStyle/>
-          <a:p>
-            <a:pPr algn="ctr">
-              <a:defRPr sz="1400">
-                <a:solidFill>
-                  <a:srgbClr val="9CA3AF"/>
-                </a:solidFill>
-              </a:defRPr>
-            </a:pPr>
-            <a:r>
-              <a:t>[parafrasear.png]</a:t>
-            </a:r>
-          </a:p>
-        </p:txBody>
-      </p:sp>
-      <p:sp>
-        <p:nvSpPr>
-          <p:cNvPr id="20" name="TextBox 19"/>
           <p:cNvSpPr txBox="1"/>
           <p:nvPr/>
         </p:nvSpPr>
@@ -5192,89 +5136,33 @@
           </a:p>
         </p:txBody>
       </p:sp>
-      <p:sp>
-        <p:nvSpPr>
-          <p:cNvPr id="18" name="Rounded Rectangle 17"/>
-          <p:cNvSpPr/>
-          <p:nvPr/>
-        </p:nvSpPr>
+      <p:pic>
+        <p:nvPicPr>
+          <p:cNvPr id="18" name="Picture 17" descr="Screenshot_chatbot_correcaoconversa.png"/>
+          <p:cNvPicPr>
+            <a:picLocks noChangeAspect="1"/>
+          </p:cNvPicPr>
+          <p:nvPr/>
+        </p:nvPicPr>
+        <p:blipFill>
+          <a:blip r:embed="rId2"/>
+          <a:stretch>
+            <a:fillRect/>
+          </a:stretch>
+        </p:blipFill>
         <p:spPr>
           <a:xfrm>
             <a:off x="4572000" y="457200"/>
-            <a:ext cx="4297680" cy="3931920"/>
-          </a:xfrm>
-          <a:prstGeom prst="roundRect">
-            <a:avLst/>
-          </a:prstGeom>
-          <a:solidFill>
-            <a:srgbClr val="372A5C"/>
-          </a:solidFill>
-          <a:ln w="25400">
-            <a:solidFill>
-              <a:srgbClr val="EC4899"/>
-            </a:solidFill>
-          </a:ln>
-        </p:spPr>
-        <p:style>
-          <a:lnRef idx="1">
-            <a:schemeClr val="accent1"/>
-          </a:lnRef>
-          <a:fillRef idx="3">
-            <a:schemeClr val="accent1"/>
-          </a:fillRef>
-          <a:effectRef idx="2">
-            <a:schemeClr val="accent1"/>
-          </a:effectRef>
-          <a:fontRef idx="minor">
-            <a:schemeClr val="lt1"/>
-          </a:fontRef>
-        </p:style>
-        <p:txBody>
-          <a:bodyPr rtlCol="0" anchor="ctr"/>
-          <a:lstStyle/>
-          <a:p>
-            <a:pPr algn="ctr"/>
-          </a:p>
-        </p:txBody>
-      </p:sp>
+            <a:ext cx="4297680" cy="5353889"/>
+          </a:xfrm>
+          <a:prstGeom prst="rect">
+            <a:avLst/>
+          </a:prstGeom>
+        </p:spPr>
+      </p:pic>
       <p:sp>
         <p:nvSpPr>
           <p:cNvPr id="19" name="TextBox 18"/>
-          <p:cNvSpPr txBox="1"/>
-          <p:nvPr/>
-        </p:nvSpPr>
-        <p:spPr>
-          <a:xfrm>
-            <a:off x="5029200" y="2103120"/>
-            <a:ext cx="3383280" cy="457200"/>
-          </a:xfrm>
-          <a:prstGeom prst="rect">
-            <a:avLst/>
-          </a:prstGeom>
-          <a:noFill/>
-        </p:spPr>
-        <p:txBody>
-          <a:bodyPr wrap="none">
-            <a:spAutoFit/>
-          </a:bodyPr>
-          <a:lstStyle/>
-          <a:p>
-            <a:pPr algn="ctr">
-              <a:defRPr sz="1400">
-                <a:solidFill>
-                  <a:srgbClr val="9CA3AF"/>
-                </a:solidFill>
-              </a:defRPr>
-            </a:pPr>
-            <a:r>
-              <a:t>[Screenshot_chatbot_correcaoconversa.png]</a:t>
-            </a:r>
-          </a:p>
-        </p:txBody>
-      </p:sp>
-      <p:sp>
-        <p:nvSpPr>
-          <p:cNvPr id="20" name="TextBox 19"/>
           <p:cNvSpPr txBox="1"/>
           <p:nvPr/>
         </p:nvSpPr>
@@ -5957,89 +5845,33 @@
           </a:p>
         </p:txBody>
       </p:sp>
-      <p:sp>
-        <p:nvSpPr>
-          <p:cNvPr id="18" name="Rounded Rectangle 17"/>
-          <p:cNvSpPr/>
-          <p:nvPr/>
-        </p:nvSpPr>
+      <p:pic>
+        <p:nvPicPr>
+          <p:cNvPr id="18" name="Picture 17" descr="Screenshot_chatbot_explicacaogramatica.png"/>
+          <p:cNvPicPr>
+            <a:picLocks noChangeAspect="1"/>
+          </p:cNvPicPr>
+          <p:nvPr/>
+        </p:nvPicPr>
+        <p:blipFill>
+          <a:blip r:embed="rId2"/>
+          <a:stretch>
+            <a:fillRect/>
+          </a:stretch>
+        </p:blipFill>
         <p:spPr>
           <a:xfrm>
             <a:off x="4572000" y="457200"/>
-            <a:ext cx="4297680" cy="3931920"/>
-          </a:xfrm>
-          <a:prstGeom prst="roundRect">
-            <a:avLst/>
-          </a:prstGeom>
-          <a:solidFill>
-            <a:srgbClr val="372A5C"/>
-          </a:solidFill>
-          <a:ln w="25400">
-            <a:solidFill>
-              <a:srgbClr val="A855F7"/>
-            </a:solidFill>
-          </a:ln>
-        </p:spPr>
-        <p:style>
-          <a:lnRef idx="1">
-            <a:schemeClr val="accent1"/>
-          </a:lnRef>
-          <a:fillRef idx="3">
-            <a:schemeClr val="accent1"/>
-          </a:fillRef>
-          <a:effectRef idx="2">
-            <a:schemeClr val="accent1"/>
-          </a:effectRef>
-          <a:fontRef idx="minor">
-            <a:schemeClr val="lt1"/>
-          </a:fontRef>
-        </p:style>
-        <p:txBody>
-          <a:bodyPr rtlCol="0" anchor="ctr"/>
-          <a:lstStyle/>
-          <a:p>
-            <a:pPr algn="ctr"/>
-          </a:p>
-        </p:txBody>
-      </p:sp>
+            <a:ext cx="4297680" cy="5436382"/>
+          </a:xfrm>
+          <a:prstGeom prst="rect">
+            <a:avLst/>
+          </a:prstGeom>
+        </p:spPr>
+      </p:pic>
       <p:sp>
         <p:nvSpPr>
           <p:cNvPr id="19" name="TextBox 18"/>
-          <p:cNvSpPr txBox="1"/>
-          <p:nvPr/>
-        </p:nvSpPr>
-        <p:spPr>
-          <a:xfrm>
-            <a:off x="5029200" y="2103120"/>
-            <a:ext cx="3383280" cy="457200"/>
-          </a:xfrm>
-          <a:prstGeom prst="rect">
-            <a:avLst/>
-          </a:prstGeom>
-          <a:noFill/>
-        </p:spPr>
-        <p:txBody>
-          <a:bodyPr wrap="none">
-            <a:spAutoFit/>
-          </a:bodyPr>
-          <a:lstStyle/>
-          <a:p>
-            <a:pPr algn="ctr">
-              <a:defRPr sz="1400">
-                <a:solidFill>
-                  <a:srgbClr val="9CA3AF"/>
-                </a:solidFill>
-              </a:defRPr>
-            </a:pPr>
-            <a:r>
-              <a:t>[Screenshot_chatbot_explicacaogramatica.png]</a:t>
-            </a:r>
-          </a:p>
-        </p:txBody>
-      </p:sp>
-      <p:sp>
-        <p:nvSpPr>
-          <p:cNvPr id="20" name="TextBox 19"/>
           <p:cNvSpPr txBox="1"/>
           <p:nvPr/>
         </p:nvSpPr>

</xml_diff>

<commit_message>
Reduz imagens do chatbot em 50% na apresentação
- Adiciona parâmetro image_width à função add_feature_slide_v2
- Aplica largura de 2.35" (50%) nos slides do chatbot

https://claude.ai/code/session_01V8Sr7tzpSFf2ivEsTTkpRr
</commit_message>
<xml_diff>
--- a/CorrectMe_Apresentacao.pptx
+++ b/CorrectMe_Apresentacao.pptx
@@ -5152,8 +5152,8 @@
         </p:blipFill>
         <p:spPr>
           <a:xfrm>
-            <a:off x="4572000" y="457200"/>
-            <a:ext cx="4297680" cy="5353889"/>
+            <a:off x="5646420" y="457200"/>
+            <a:ext cx="2148840" cy="2676945"/>
           </a:xfrm>
           <a:prstGeom prst="rect">
             <a:avLst/>
@@ -5861,8 +5861,8 @@
         </p:blipFill>
         <p:spPr>
           <a:xfrm>
-            <a:off x="4572000" y="457200"/>
-            <a:ext cx="4297680" cy="5436382"/>
+            <a:off x="5646420" y="457200"/>
+            <a:ext cx="2148840" cy="2718191"/>
           </a:xfrm>
           <a:prstGeom prst="rect">
             <a:avLst/>

</xml_diff>